<commit_message>
fix: Seedance 2.0 极限版统一改为 Seedance 2.0
</commit_message>
<xml_diff>
--- a/pitch/ai-marketing-2026.pptx
+++ b/pitch/ai-marketing-2026.pptx
@@ -37670,7 +37670,7 @@
                 </a:solidFill>
                 <a:latin typeface="Inter"/>
               </a:rPr>
-              <a:t>可灵 3.0 Pro · Seedance 2.0 极限版</a:t>
+              <a:t>可灵 3.0 Pro · Seedance 2.0</a:t>
             </a:r>
           </a:p>
         </p:txBody>
@@ -42733,7 +42733,7 @@
                 </a:solidFill>
                 <a:latin typeface="Microsoft YaHei"/>
               </a:rPr>
-              <a:t>AI 视频生成  —  可灵 3.0 Pro × Seedance 2.0 极限版</a:t>
+              <a:t>AI 视频生成  —  可灵 3.0 Pro × Seedance 2.0</a:t>
             </a:r>
           </a:p>
         </p:txBody>
@@ -43543,7 +43543,7 @@
                 </a:solidFill>
                 <a:latin typeface="Inter"/>
               </a:rPr>
-              <a:t>Seedance 2.0 极限版</a:t>
+              <a:t>Seedance 2.0</a:t>
             </a:r>
           </a:p>
         </p:txBody>

</xml_diff>